<commit_message>
docs: sync hackathon submission artifacts
</commit_message>
<xml_diff>
--- a/docs/Brian_AI_pitch_deck.pptx
+++ b/docs/Brian_AI_pitch_deck.pptx
@@ -5413,7 +5413,7 @@
                   <a:srgbClr val="555555"/>
                 </a:solidFill>
               </a:rPr>
-              <a:t>OpenRouter, ChromaDB, Neo4j AuraDB</a:t>
+              <a:t>OpenRouter, SQLite vectors, Neo4j AuraDB</a:t>
             </a:r>
           </a:p>
         </p:txBody>
@@ -7031,7 +7031,7 @@
                   <a:srgbClr val="050505"/>
                 </a:solidFill>
               </a:rPr>
-              <a:t>Enable OpenRouter, ChromaDB, and Neo4j AuraDB with production credentials.</a:t>
+              <a:t>Enable OpenRouter and Neo4j AuraDB; SQLite vectors require no separate credentials.</a:t>
             </a:r>
           </a:p>
         </p:txBody>

</xml_diff>